<commit_message>
docs: update presentation with manual fixes
Co-Authored-By: Claude Opus 4.6 <noreply@anthropic.com>
</commit_message>
<xml_diff>
--- a/examples/test_mnist/output_fp8qat/FP8_QAT_Cipher_Inference.pptx
+++ b/examples/test_mnist/output_fp8qat/FP8_QAT_Cipher_Inference.pptx
@@ -3124,6 +3124,50 @@
             <a:avLst/>
           </a:prstGeom>
           <a:solidFill>
+            <a:srgbClr val="FFD700"/>
+          </a:solidFill>
+          <a:ln>
+            <a:noFill/>
+          </a:ln>
+          <a:effectLst/>
+        </p:spPr>
+        <p:style>
+          <a:lnRef idx="1">
+            <a:schemeClr val="accent1"/>
+          </a:lnRef>
+          <a:fillRef idx="3">
+            <a:schemeClr val="accent1"/>
+          </a:fillRef>
+          <a:effectRef idx="2">
+            <a:schemeClr val="accent1"/>
+          </a:effectRef>
+          <a:fontRef idx="minor">
+            <a:schemeClr val="lt1"/>
+          </a:fontRef>
+        </p:style>
+        <p:txBody>
+          <a:bodyPr rtlCol="0" anchor="ctr"/>
+          <a:lstStyle/>
+          <a:p>
+            <a:pPr algn="ctr"/>
+          </a:p>
+        </p:txBody>
+      </p:sp>
+      <p:sp>
+        <p:nvSpPr>
+          <p:cNvPr id="3" name="Rounded Rectangle 2"/>
+          <p:cNvSpPr/>
+          <p:nvPr/>
+        </p:nvSpPr>
+        <p:spPr>
+          <a:xfrm>
+            <a:off x="0" y="54864"/>
+            <a:ext cx="12188952" cy="27432"/>
+          </a:xfrm>
+          <a:prstGeom prst="roundRect">
+            <a:avLst/>
+          </a:prstGeom>
+          <a:solidFill>
             <a:srgbClr val="00BFD8"/>
           </a:solidFill>
           <a:ln>
@@ -3155,20 +3199,92 @@
       </p:sp>
       <p:sp>
         <p:nvSpPr>
-          <p:cNvPr id="3" name="Rounded Rectangle 2"/>
+          <p:cNvPr id="4" name="TextBox 3"/>
+          <p:cNvSpPr txBox="1"/>
+          <p:nvPr/>
+        </p:nvSpPr>
+        <p:spPr>
+          <a:xfrm>
+            <a:off x="914400" y="822960"/>
+            <a:ext cx="10332720" cy="731520"/>
+          </a:xfrm>
+          <a:prstGeom prst="rect">
+            <a:avLst/>
+          </a:prstGeom>
+          <a:noFill/>
+        </p:spPr>
+        <p:txBody>
+          <a:bodyPr wrap="square">
+            <a:spAutoFit/>
+          </a:bodyPr>
+          <a:lstStyle/>
+          <a:p>
+            <a:pPr algn="ctr">
+              <a:defRPr sz="4000" b="1">
+                <a:solidFill>
+                  <a:srgbClr val="FFD700"/>
+                </a:solidFill>
+                <a:latin typeface="Consolas"/>
+              </a:defRPr>
+            </a:pPr>
+            <a:r>
+              <a:t>CKKS Parameter Selection Skill</a:t>
+            </a:r>
+          </a:p>
+        </p:txBody>
+      </p:sp>
+      <p:sp>
+        <p:nvSpPr>
+          <p:cNvPr id="5" name="TextBox 4"/>
+          <p:cNvSpPr txBox="1"/>
+          <p:nvPr/>
+        </p:nvSpPr>
+        <p:spPr>
+          <a:xfrm>
+            <a:off x="914400" y="1645920"/>
+            <a:ext cx="10332720" cy="548640"/>
+          </a:xfrm>
+          <a:prstGeom prst="rect">
+            <a:avLst/>
+          </a:prstGeom>
+          <a:noFill/>
+        </p:spPr>
+        <p:txBody>
+          <a:bodyPr wrap="square">
+            <a:spAutoFit/>
+          </a:bodyPr>
+          <a:lstStyle/>
+          <a:p>
+            <a:pPr algn="ctr">
+              <a:defRPr sz="2400" b="1">
+                <a:solidFill>
+                  <a:srgbClr val="FFFFFF"/>
+                </a:solidFill>
+                <a:latin typeface="Consolas"/>
+              </a:defRPr>
+            </a:pPr>
+            <a:r>
+              <a:t>for QAT Model Encrypted Inference</a:t>
+            </a:r>
+          </a:p>
+        </p:txBody>
+      </p:sp>
+      <p:sp>
+        <p:nvSpPr>
+          <p:cNvPr id="6" name="Rounded Rectangle 5"/>
           <p:cNvSpPr/>
           <p:nvPr/>
         </p:nvSpPr>
         <p:spPr>
           <a:xfrm>
-            <a:off x="0" y="54864"/>
-            <a:ext cx="12188952" cy="27432"/>
+            <a:off x="4114800" y="2377440"/>
+            <a:ext cx="3931920" cy="27432"/>
           </a:xfrm>
           <a:prstGeom prst="roundRect">
             <a:avLst/>
           </a:prstGeom>
           <a:solidFill>
-            <a:srgbClr val="7C3AED"/>
+            <a:srgbClr val="00BFD8"/>
           </a:solidFill>
           <a:ln>
             <a:noFill/>
@@ -3199,86 +3315,14 @@
       </p:sp>
       <p:sp>
         <p:nvSpPr>
-          <p:cNvPr id="4" name="TextBox 3"/>
-          <p:cNvSpPr txBox="1"/>
-          <p:nvPr/>
-        </p:nvSpPr>
-        <p:spPr>
-          <a:xfrm>
-            <a:off x="1371600" y="1371600"/>
-            <a:ext cx="9144000" cy="1097280"/>
-          </a:xfrm>
-          <a:prstGeom prst="rect">
-            <a:avLst/>
-          </a:prstGeom>
-          <a:noFill/>
-        </p:spPr>
-        <p:txBody>
-          <a:bodyPr wrap="square">
-            <a:spAutoFit/>
-          </a:bodyPr>
-          <a:lstStyle/>
-          <a:p>
-            <a:pPr algn="ctr">
-              <a:defRPr sz="4000" b="1">
-                <a:solidFill>
-                  <a:srgbClr val="FFFFFF"/>
-                </a:solidFill>
-                <a:latin typeface="Consolas"/>
-              </a:defRPr>
-            </a:pPr>
-            <a:r>
-              <a:t>FP8 Quantized Cipher Inference</a:t>
-            </a:r>
-          </a:p>
-        </p:txBody>
-      </p:sp>
-      <p:sp>
-        <p:nvSpPr>
-          <p:cNvPr id="5" name="TextBox 4"/>
-          <p:cNvSpPr txBox="1"/>
-          <p:nvPr/>
-        </p:nvSpPr>
-        <p:spPr>
-          <a:xfrm>
-            <a:off x="1371600" y="2560320"/>
-            <a:ext cx="9144000" cy="731520"/>
-          </a:xfrm>
-          <a:prstGeom prst="rect">
-            <a:avLst/>
-          </a:prstGeom>
-          <a:noFill/>
-        </p:spPr>
-        <p:txBody>
-          <a:bodyPr wrap="square">
-            <a:spAutoFit/>
-          </a:bodyPr>
-          <a:lstStyle/>
-          <a:p>
-            <a:pPr algn="ctr">
-              <a:defRPr sz="1800" b="0">
-                <a:solidFill>
-                  <a:srgbClr val="00BFD8"/>
-                </a:solidFill>
-                <a:latin typeface="Consolas"/>
-              </a:defRPr>
-            </a:pPr>
-            <a:r>
-              <a:t>Custom CKKS Parameters for N=8192 Encrypted Neural Network Inference</a:t>
-            </a:r>
-          </a:p>
-        </p:txBody>
-      </p:sp>
-      <p:sp>
-        <p:nvSpPr>
-          <p:cNvPr id="6" name="TextBox 5"/>
-          <p:cNvSpPr txBox="1"/>
-          <p:nvPr/>
-        </p:nvSpPr>
-        <p:spPr>
-          <a:xfrm>
-            <a:off x="1371600" y="3840480"/>
-            <a:ext cx="9144000" cy="457200"/>
+          <p:cNvPr id="7" name="TextBox 6"/>
+          <p:cNvSpPr txBox="1"/>
+          <p:nvPr/>
+        </p:nvSpPr>
+        <p:spPr>
+          <a:xfrm>
+            <a:off x="914400" y="2651760"/>
+            <a:ext cx="10332720" cy="457200"/>
           </a:xfrm>
           <a:prstGeom prst="rect">
             <a:avLst/>
@@ -3300,21 +3344,529 @@
               </a:defRPr>
             </a:pPr>
             <a:r>
-              <a:t>5.6x Speedup  |  ~127-bit Security  |  PASS Verification</a:t>
-            </a:r>
-          </a:p>
-        </p:txBody>
-      </p:sp>
-      <p:sp>
-        <p:nvSpPr>
-          <p:cNvPr id="7" name="TextBox 6"/>
-          <p:cNvSpPr txBox="1"/>
-          <p:nvPr/>
-        </p:nvSpPr>
-        <p:spPr>
-          <a:xfrm>
-            <a:off x="1371600" y="5029200"/>
-            <a:ext cx="9144000" cy="457200"/>
+              <a:t>A reusable methodology to design custom CKKS parameters</a:t>
+            </a:r>
+          </a:p>
+        </p:txBody>
+      </p:sp>
+      <p:sp>
+        <p:nvSpPr>
+          <p:cNvPr id="8" name="TextBox 7"/>
+          <p:cNvSpPr txBox="1"/>
+          <p:nvPr/>
+        </p:nvSpPr>
+        <p:spPr>
+          <a:xfrm>
+            <a:off x="914400" y="3063240"/>
+            <a:ext cx="10332720" cy="457200"/>
+          </a:xfrm>
+          <a:prstGeom prst="rect">
+            <a:avLst/>
+          </a:prstGeom>
+          <a:noFill/>
+        </p:spPr>
+        <p:txBody>
+          <a:bodyPr wrap="square">
+            <a:spAutoFit/>
+          </a:bodyPr>
+          <a:lstStyle/>
+          <a:p>
+            <a:pPr algn="ctr">
+              <a:defRPr sz="1600" b="0">
+                <a:solidFill>
+                  <a:srgbClr val="A0AEC0"/>
+                </a:solidFill>
+                <a:latin typeface="Consolas"/>
+              </a:defRPr>
+            </a:pPr>
+            <a:r>
+              <a:t>that exploit QAT noise tolerance for smaller ring dimensions</a:t>
+            </a:r>
+          </a:p>
+        </p:txBody>
+      </p:sp>
+      <p:sp>
+        <p:nvSpPr>
+          <p:cNvPr id="9" name="Rounded Rectangle 8"/>
+          <p:cNvSpPr/>
+          <p:nvPr/>
+        </p:nvSpPr>
+        <p:spPr>
+          <a:xfrm>
+            <a:off x="1293876" y="3931920"/>
+            <a:ext cx="2194560" cy="1188720"/>
+          </a:xfrm>
+          <a:prstGeom prst="roundRect">
+            <a:avLst/>
+          </a:prstGeom>
+          <a:solidFill>
+            <a:srgbClr val="1A253C"/>
+          </a:solidFill>
+          <a:ln w="19050">
+            <a:solidFill>
+              <a:srgbClr val="00BFD8"/>
+            </a:solidFill>
+          </a:ln>
+          <a:effectLst/>
+        </p:spPr>
+        <p:style>
+          <a:lnRef idx="1">
+            <a:schemeClr val="accent1"/>
+          </a:lnRef>
+          <a:fillRef idx="3">
+            <a:schemeClr val="accent1"/>
+          </a:fillRef>
+          <a:effectRef idx="2">
+            <a:schemeClr val="accent1"/>
+          </a:effectRef>
+          <a:fontRef idx="minor">
+            <a:schemeClr val="lt1"/>
+          </a:fontRef>
+        </p:style>
+        <p:txBody>
+          <a:bodyPr rtlCol="0" anchor="ctr"/>
+          <a:lstStyle/>
+          <a:p>
+            <a:pPr algn="ctr"/>
+          </a:p>
+        </p:txBody>
+      </p:sp>
+      <p:sp>
+        <p:nvSpPr>
+          <p:cNvPr id="10" name="TextBox 9"/>
+          <p:cNvSpPr txBox="1"/>
+          <p:nvPr/>
+        </p:nvSpPr>
+        <p:spPr>
+          <a:xfrm>
+            <a:off x="1293876" y="4023360"/>
+            <a:ext cx="2194560" cy="548640"/>
+          </a:xfrm>
+          <a:prstGeom prst="rect">
+            <a:avLst/>
+          </a:prstGeom>
+          <a:noFill/>
+        </p:spPr>
+        <p:txBody>
+          <a:bodyPr wrap="square">
+            <a:spAutoFit/>
+          </a:bodyPr>
+          <a:lstStyle/>
+          <a:p>
+            <a:pPr algn="ctr">
+              <a:defRPr sz="2800" b="1">
+                <a:solidFill>
+                  <a:srgbClr val="00BFD8"/>
+                </a:solidFill>
+                <a:latin typeface="Consolas"/>
+              </a:defRPr>
+            </a:pPr>
+            <a:r>
+              <a:t>N=8,192</a:t>
+            </a:r>
+          </a:p>
+        </p:txBody>
+      </p:sp>
+      <p:sp>
+        <p:nvSpPr>
+          <p:cNvPr id="11" name="TextBox 10"/>
+          <p:cNvSpPr txBox="1"/>
+          <p:nvPr/>
+        </p:nvSpPr>
+        <p:spPr>
+          <a:xfrm>
+            <a:off x="1293876" y="4572000"/>
+            <a:ext cx="2194560" cy="320040"/>
+          </a:xfrm>
+          <a:prstGeom prst="rect">
+            <a:avLst/>
+          </a:prstGeom>
+          <a:noFill/>
+        </p:spPr>
+        <p:txBody>
+          <a:bodyPr wrap="square">
+            <a:spAutoFit/>
+          </a:bodyPr>
+          <a:lstStyle/>
+          <a:p>
+            <a:pPr algn="ctr">
+              <a:defRPr sz="1100" b="0">
+                <a:solidFill>
+                  <a:srgbClr val="A0AEC0"/>
+                </a:solidFill>
+                <a:latin typeface="Consolas"/>
+              </a:defRPr>
+            </a:pPr>
+            <a:r>
+              <a:t>Ring Dimension</a:t>
+            </a:r>
+          </a:p>
+        </p:txBody>
+      </p:sp>
+      <p:sp>
+        <p:nvSpPr>
+          <p:cNvPr id="12" name="Rounded Rectangle 11"/>
+          <p:cNvSpPr/>
+          <p:nvPr/>
+        </p:nvSpPr>
+        <p:spPr>
+          <a:xfrm>
+            <a:off x="3762756" y="3931920"/>
+            <a:ext cx="2194560" cy="1188720"/>
+          </a:xfrm>
+          <a:prstGeom prst="roundRect">
+            <a:avLst/>
+          </a:prstGeom>
+          <a:solidFill>
+            <a:srgbClr val="1A253C"/>
+          </a:solidFill>
+          <a:ln w="19050">
+            <a:solidFill>
+              <a:srgbClr val="10B981"/>
+            </a:solidFill>
+          </a:ln>
+          <a:effectLst/>
+        </p:spPr>
+        <p:style>
+          <a:lnRef idx="1">
+            <a:schemeClr val="accent1"/>
+          </a:lnRef>
+          <a:fillRef idx="3">
+            <a:schemeClr val="accent1"/>
+          </a:fillRef>
+          <a:effectRef idx="2">
+            <a:schemeClr val="accent1"/>
+          </a:effectRef>
+          <a:fontRef idx="minor">
+            <a:schemeClr val="lt1"/>
+          </a:fontRef>
+        </p:style>
+        <p:txBody>
+          <a:bodyPr rtlCol="0" anchor="ctr"/>
+          <a:lstStyle/>
+          <a:p>
+            <a:pPr algn="ctr"/>
+          </a:p>
+        </p:txBody>
+      </p:sp>
+      <p:sp>
+        <p:nvSpPr>
+          <p:cNvPr id="13" name="TextBox 12"/>
+          <p:cNvSpPr txBox="1"/>
+          <p:nvPr/>
+        </p:nvSpPr>
+        <p:spPr>
+          <a:xfrm>
+            <a:off x="3762756" y="4023360"/>
+            <a:ext cx="2194560" cy="548640"/>
+          </a:xfrm>
+          <a:prstGeom prst="rect">
+            <a:avLst/>
+          </a:prstGeom>
+          <a:noFill/>
+        </p:spPr>
+        <p:txBody>
+          <a:bodyPr wrap="square">
+            <a:spAutoFit/>
+          </a:bodyPr>
+          <a:lstStyle/>
+          <a:p>
+            <a:pPr algn="ctr">
+              <a:defRPr sz="2800" b="1">
+                <a:solidFill>
+                  <a:srgbClr val="10B981"/>
+                </a:solidFill>
+                <a:latin typeface="Consolas"/>
+              </a:defRPr>
+            </a:pPr>
+            <a:r>
+              <a:t>5.6x</a:t>
+            </a:r>
+          </a:p>
+        </p:txBody>
+      </p:sp>
+      <p:sp>
+        <p:nvSpPr>
+          <p:cNvPr id="14" name="TextBox 13"/>
+          <p:cNvSpPr txBox="1"/>
+          <p:nvPr/>
+        </p:nvSpPr>
+        <p:spPr>
+          <a:xfrm>
+            <a:off x="3762756" y="4572000"/>
+            <a:ext cx="2194560" cy="320040"/>
+          </a:xfrm>
+          <a:prstGeom prst="rect">
+            <a:avLst/>
+          </a:prstGeom>
+          <a:noFill/>
+        </p:spPr>
+        <p:txBody>
+          <a:bodyPr wrap="square">
+            <a:spAutoFit/>
+          </a:bodyPr>
+          <a:lstStyle/>
+          <a:p>
+            <a:pPr algn="ctr">
+              <a:defRPr sz="1100" b="0">
+                <a:solidFill>
+                  <a:srgbClr val="A0AEC0"/>
+                </a:solidFill>
+                <a:latin typeface="Consolas"/>
+              </a:defRPr>
+            </a:pPr>
+            <a:r>
+              <a:t>Speedup</a:t>
+            </a:r>
+          </a:p>
+        </p:txBody>
+      </p:sp>
+      <p:sp>
+        <p:nvSpPr>
+          <p:cNvPr id="15" name="Rounded Rectangle 14"/>
+          <p:cNvSpPr/>
+          <p:nvPr/>
+        </p:nvSpPr>
+        <p:spPr>
+          <a:xfrm>
+            <a:off x="6231636" y="3931920"/>
+            <a:ext cx="2194560" cy="1188720"/>
+          </a:xfrm>
+          <a:prstGeom prst="roundRect">
+            <a:avLst/>
+          </a:prstGeom>
+          <a:solidFill>
+            <a:srgbClr val="1A253C"/>
+          </a:solidFill>
+          <a:ln w="19050">
+            <a:solidFill>
+              <a:srgbClr val="F97B16"/>
+            </a:solidFill>
+          </a:ln>
+          <a:effectLst/>
+        </p:spPr>
+        <p:style>
+          <a:lnRef idx="1">
+            <a:schemeClr val="accent1"/>
+          </a:lnRef>
+          <a:fillRef idx="3">
+            <a:schemeClr val="accent1"/>
+          </a:fillRef>
+          <a:effectRef idx="2">
+            <a:schemeClr val="accent1"/>
+          </a:effectRef>
+          <a:fontRef idx="minor">
+            <a:schemeClr val="lt1"/>
+          </a:fontRef>
+        </p:style>
+        <p:txBody>
+          <a:bodyPr rtlCol="0" anchor="ctr"/>
+          <a:lstStyle/>
+          <a:p>
+            <a:pPr algn="ctr"/>
+          </a:p>
+        </p:txBody>
+      </p:sp>
+      <p:sp>
+        <p:nvSpPr>
+          <p:cNvPr id="16" name="TextBox 15"/>
+          <p:cNvSpPr txBox="1"/>
+          <p:nvPr/>
+        </p:nvSpPr>
+        <p:spPr>
+          <a:xfrm>
+            <a:off x="6231636" y="4023360"/>
+            <a:ext cx="2194560" cy="548640"/>
+          </a:xfrm>
+          <a:prstGeom prst="rect">
+            <a:avLst/>
+          </a:prstGeom>
+          <a:noFill/>
+        </p:spPr>
+        <p:txBody>
+          <a:bodyPr wrap="square">
+            <a:spAutoFit/>
+          </a:bodyPr>
+          <a:lstStyle/>
+          <a:p>
+            <a:pPr algn="ctr">
+              <a:defRPr sz="2800" b="1">
+                <a:solidFill>
+                  <a:srgbClr val="F97B16"/>
+                </a:solidFill>
+                <a:latin typeface="Consolas"/>
+              </a:defRPr>
+            </a:pPr>
+            <a:r>
+              <a:t>~127-bit</a:t>
+            </a:r>
+          </a:p>
+        </p:txBody>
+      </p:sp>
+      <p:sp>
+        <p:nvSpPr>
+          <p:cNvPr id="17" name="TextBox 16"/>
+          <p:cNvSpPr txBox="1"/>
+          <p:nvPr/>
+        </p:nvSpPr>
+        <p:spPr>
+          <a:xfrm>
+            <a:off x="6231636" y="4572000"/>
+            <a:ext cx="2194560" cy="320040"/>
+          </a:xfrm>
+          <a:prstGeom prst="rect">
+            <a:avLst/>
+          </a:prstGeom>
+          <a:noFill/>
+        </p:spPr>
+        <p:txBody>
+          <a:bodyPr wrap="square">
+            <a:spAutoFit/>
+          </a:bodyPr>
+          <a:lstStyle/>
+          <a:p>
+            <a:pPr algn="ctr">
+              <a:defRPr sz="1100" b="0">
+                <a:solidFill>
+                  <a:srgbClr val="A0AEC0"/>
+                </a:solidFill>
+                <a:latin typeface="Consolas"/>
+              </a:defRPr>
+            </a:pPr>
+            <a:r>
+              <a:t>Security</a:t>
+            </a:r>
+          </a:p>
+        </p:txBody>
+      </p:sp>
+      <p:sp>
+        <p:nvSpPr>
+          <p:cNvPr id="18" name="Rounded Rectangle 17"/>
+          <p:cNvSpPr/>
+          <p:nvPr/>
+        </p:nvSpPr>
+        <p:spPr>
+          <a:xfrm>
+            <a:off x="8700516" y="3931920"/>
+            <a:ext cx="2194560" cy="1188720"/>
+          </a:xfrm>
+          <a:prstGeom prst="roundRect">
+            <a:avLst/>
+          </a:prstGeom>
+          <a:solidFill>
+            <a:srgbClr val="1A253C"/>
+          </a:solidFill>
+          <a:ln w="19050">
+            <a:solidFill>
+              <a:srgbClr val="10B981"/>
+            </a:solidFill>
+          </a:ln>
+          <a:effectLst/>
+        </p:spPr>
+        <p:style>
+          <a:lnRef idx="1">
+            <a:schemeClr val="accent1"/>
+          </a:lnRef>
+          <a:fillRef idx="3">
+            <a:schemeClr val="accent1"/>
+          </a:fillRef>
+          <a:effectRef idx="2">
+            <a:schemeClr val="accent1"/>
+          </a:effectRef>
+          <a:fontRef idx="minor">
+            <a:schemeClr val="lt1"/>
+          </a:fontRef>
+        </p:style>
+        <p:txBody>
+          <a:bodyPr rtlCol="0" anchor="ctr"/>
+          <a:lstStyle/>
+          <a:p>
+            <a:pPr algn="ctr"/>
+          </a:p>
+        </p:txBody>
+      </p:sp>
+      <p:sp>
+        <p:nvSpPr>
+          <p:cNvPr id="19" name="TextBox 18"/>
+          <p:cNvSpPr txBox="1"/>
+          <p:nvPr/>
+        </p:nvSpPr>
+        <p:spPr>
+          <a:xfrm>
+            <a:off x="8700516" y="4023360"/>
+            <a:ext cx="2194560" cy="548640"/>
+          </a:xfrm>
+          <a:prstGeom prst="rect">
+            <a:avLst/>
+          </a:prstGeom>
+          <a:noFill/>
+        </p:spPr>
+        <p:txBody>
+          <a:bodyPr wrap="square">
+            <a:spAutoFit/>
+          </a:bodyPr>
+          <a:lstStyle/>
+          <a:p>
+            <a:pPr algn="ctr">
+              <a:defRPr sz="2800" b="1">
+                <a:solidFill>
+                  <a:srgbClr val="10B981"/>
+                </a:solidFill>
+                <a:latin typeface="Consolas"/>
+              </a:defRPr>
+            </a:pPr>
+            <a:r>
+              <a:t>PASS</a:t>
+            </a:r>
+          </a:p>
+        </p:txBody>
+      </p:sp>
+      <p:sp>
+        <p:nvSpPr>
+          <p:cNvPr id="20" name="TextBox 19"/>
+          <p:cNvSpPr txBox="1"/>
+          <p:nvPr/>
+        </p:nvSpPr>
+        <p:spPr>
+          <a:xfrm>
+            <a:off x="8700516" y="4572000"/>
+            <a:ext cx="2194560" cy="320040"/>
+          </a:xfrm>
+          <a:prstGeom prst="rect">
+            <a:avLst/>
+          </a:prstGeom>
+          <a:noFill/>
+        </p:spPr>
+        <p:txBody>
+          <a:bodyPr wrap="square">
+            <a:spAutoFit/>
+          </a:bodyPr>
+          <a:lstStyle/>
+          <a:p>
+            <a:pPr algn="ctr">
+              <a:defRPr sz="1100" b="0">
+                <a:solidFill>
+                  <a:srgbClr val="A0AEC0"/>
+                </a:solidFill>
+                <a:latin typeface="Consolas"/>
+              </a:defRPr>
+            </a:pPr>
+            <a:r>
+              <a:t>Verification</a:t>
+            </a:r>
+          </a:p>
+        </p:txBody>
+      </p:sp>
+      <p:sp>
+        <p:nvSpPr>
+          <p:cNvPr id="21" name="TextBox 20"/>
+          <p:cNvSpPr txBox="1"/>
+          <p:nvPr/>
+        </p:nvSpPr>
+        <p:spPr>
+          <a:xfrm>
+            <a:off x="914400" y="5394960"/>
+            <a:ext cx="10332720" cy="365760"/>
           </a:xfrm>
           <a:prstGeom prst="rect">
             <a:avLst/>
@@ -3330,6 +3882,42 @@
             <a:pPr algn="ctr">
               <a:defRPr sz="1300" b="0">
                 <a:solidFill>
+                  <a:srgbClr val="00BFD8"/>
+                </a:solidFill>
+                <a:latin typeface="Consolas"/>
+              </a:defRPr>
+            </a:pPr>
+            <a:r>
+              <a:t>Case Study: FP8 QAT MNIST  |  1,194 ms Inference  |  24-bit CKKS Primes</a:t>
+            </a:r>
+          </a:p>
+        </p:txBody>
+      </p:sp>
+      <p:sp>
+        <p:nvSpPr>
+          <p:cNvPr id="22" name="TextBox 21"/>
+          <p:cNvSpPr txBox="1"/>
+          <p:nvPr/>
+        </p:nvSpPr>
+        <p:spPr>
+          <a:xfrm>
+            <a:off x="914400" y="5943600"/>
+            <a:ext cx="10332720" cy="365760"/>
+          </a:xfrm>
+          <a:prstGeom prst="rect">
+            <a:avLst/>
+          </a:prstGeom>
+          <a:noFill/>
+        </p:spPr>
+        <p:txBody>
+          <a:bodyPr wrap="square">
+            <a:spAutoFit/>
+          </a:bodyPr>
+          <a:lstStyle/>
+          <a:p>
+            <a:pPr algn="ctr">
+              <a:defRPr sz="1200" b="0">
+                <a:solidFill>
                   <a:srgbClr val="64748B"/>
                 </a:solidFill>
                 <a:latin typeface="Consolas"/>
@@ -3343,7 +3931,7 @@
       </p:sp>
       <p:sp>
         <p:nvSpPr>
-          <p:cNvPr id="8" name="TextBox 7"/>
+          <p:cNvPr id="23" name="TextBox 22"/>
           <p:cNvSpPr txBox="1"/>
           <p:nvPr/>
         </p:nvSpPr>

</xml_diff>